<commit_message>
Competition pair: FireANTs with IMPACT features in the figure and the table; the zoom where the correction is largest
</commit_message>
<xml_diff>
--- a/talk/KonfAI_registration_5min.pptx
+++ b/talk/KonfAI_registration_5min.pptx
@@ -600,19 +600,19 @@
           <a:p/>
           <a:p>
             <a:r>
-              <a:t>And the competition pair: DTI FA onto PS-OCT retardance, on a 0.4-millimetre grid, with the three backends through the same pipeline.</a:t>
+              <a:t>And the competition pair: DTI FA onto PS-OCT retardance, on a 0.4-millimetre grid, through the same pipeline.</a:t>
             </a:r>
           </a:p>
           <a:p/>
           <a:p>
             <a:r>
-              <a:t>The gold line is the retardance's white matter, the same in every panel; the grey image is the FA, moving. After the affine alone, look at the zoom: the tract sits next to the gold line. After elastix and FireANTs, it sits right under it.</a:t>
+              <a:t>The gold line is the retardance's white matter, the same in every panel; the grey image is the FA, moving. After the affine alone, look at the zoom: the tract sits next to the gold line. After each registration, it sits right under it.</a:t>
             </a:r>
           </a:p>
           <a:p/>
           <a:p>
             <a:r>
-              <a:t>In numbers, elastix and FireANTs both get down to one voxel with zero folding, and FireANTs does it with the smallest deformation. ConvexAdam aligns the inside too, but it folds a bit of tissue and stretches the edges.</a:t>
+              <a:t>In numbers, elastix and FireANTs both get down to one voxel with zero folding, and FireANTs does it with the smallest deformation. And here's the point of the talk: FireANTs with IMPACT features from TotalSegmentator, instead of cross-correlation, lands at the same accuracy, with no folding, on both subjects. ConvexAdam aligns the inside too, but it folds a bit of tissue and stretches the edges.</a:t>
             </a:r>
           </a:p>
         </p:txBody>
@@ -4999,7 +4999,7 @@
                 </a:solidFill>
                 <a:latin typeface="Alegreya"/>
               </a:rPr>
-              <a:t>Three engines, two subjects</a:t>
+              <a:t>Same pipeline, intensity losses or IMPACT features</a:t>
             </a:r>
           </a:p>
         </p:txBody>
@@ -5072,7 +5072,7 @@
         <p:spPr>
           <a:xfrm>
             <a:off x="740664" y="4341114"/>
-            <a:ext cx="4969295" cy="425196"/>
+            <a:ext cx="4969295" cy="466344"/>
           </a:xfrm>
           <a:prstGeom prst="rect">
             <a:avLst/>
@@ -5103,7 +5103,7 @@
                 </a:solidFill>
                 <a:latin typeface="Poppins"/>
               </a:rPr>
-              <a:t>the retardance's white-matter outline, the same in every panel · grey: the FA after each stage · aligned = the bright tracts lie under the gold lines · bottom: 24 mm zoom</a:t>
+              <a:t>the retardance's white-matter outline, the same in every panel · grey: the FA after each stage · aligned = the bright tracts lie under the gold lines · bottom: the 24 mm box with the largest correction</a:t>
             </a:r>
           </a:p>
         </p:txBody>
@@ -5117,7 +5117,7 @@
         <p:spPr>
           <a:xfrm>
             <a:off x="5897879" y="1097280"/>
-            <a:ext cx="2811779" cy="946403"/>
+            <a:ext cx="2811779" cy="672084"/>
           </a:xfrm>
           <a:prstGeom prst="roundRect">
             <a:avLst>
@@ -5149,7 +5149,7 @@
           </a:fontRef>
         </p:style>
         <p:txBody>
-          <a:bodyPr rtlCol="0" anchor="t" wrap="square" lIns="89154" rIns="89154" tIns="89154" bIns="89154">
+          <a:bodyPr rtlCol="0" anchor="t" wrap="square" lIns="68580" rIns="68580" tIns="68580" bIns="68580">
             <a:noAutofit/>
           </a:bodyPr>
           <a:lstStyle/>
@@ -5166,13 +5166,13 @@
               </a:spcAft>
             </a:pPr>
             <a:r>
-              <a:rPr sz="1200" b="1" i="0">
+              <a:rPr sz="900" b="1" i="0">
                 <a:solidFill>
                   <a:srgbClr val="212121"/>
                 </a:solidFill>
                 <a:latin typeface="Poppins"/>
               </a:rPr>
-              <a:t>elastix MI + bending</a:t>
+              <a:t>elastix · MI + bending</a:t>
             </a:r>
           </a:p>
           <a:p>
@@ -5184,17 +5184,53 @@
                 <a:spcPts val="0"/>
               </a:spcBef>
               <a:spcAft>
-                <a:spcPts val="0"/>
-              </a:spcAft>
-            </a:pPr>
-            <a:r>
-              <a:rPr sz="1650" b="1" i="0">
+                <a:spcPts val="75"/>
+              </a:spcAft>
+            </a:pPr>
+            <a:r>
+              <a:rPr sz="750" b="0" i="0">
+                <a:solidFill>
+                  <a:srgbClr val="595959"/>
+                </a:solidFill>
+                <a:latin typeface="Consolas"/>
+              </a:rPr>
+              <a:t>v </a:t>
+            </a:r>
+            <a:r>
+              <a:rPr sz="1050" b="1" i="0">
                 <a:solidFill>
                   <a:srgbClr val="212121"/>
                 </a:solidFill>
                 <a:latin typeface="Consolas"/>
               </a:rPr>
-              <a:t>0.40 / 0.40 mm</a:t>
+              <a:t>0.40 / 0.40</a:t>
+            </a:r>
+            <a:r>
+              <a:rPr sz="750" b="0" i="0">
+                <a:solidFill>
+                  <a:srgbClr val="595959"/>
+                </a:solidFill>
+                <a:latin typeface="Consolas"/>
+              </a:rPr>
+              <a:t>   m </a:t>
+            </a:r>
+            <a:r>
+              <a:rPr sz="1050" b="1" i="0">
+                <a:solidFill>
+                  <a:srgbClr val="212121"/>
+                </a:solidFill>
+                <a:latin typeface="Consolas"/>
+              </a:rPr>
+              <a:t>0.57 / 0.40</a:t>
+            </a:r>
+            <a:r>
+              <a:rPr sz="750" b="0" i="0">
+                <a:solidFill>
+                  <a:srgbClr val="595959"/>
+                </a:solidFill>
+                <a:latin typeface="Consolas"/>
+              </a:rPr>
+              <a:t> mm</a:t>
             </a:r>
           </a:p>
           <a:p>
@@ -5206,11 +5242,11 @@
                 <a:spcPts val="0"/>
               </a:spcBef>
               <a:spcAft>
-                <a:spcPts val="75"/>
-              </a:spcAft>
-            </a:pPr>
-            <a:r>
-              <a:rPr sz="900" b="1" i="0">
+                <a:spcPts val="0"/>
+              </a:spcAft>
+            </a:pPr>
+            <a:r>
+              <a:rPr sz="825" b="1" i="0">
                 <a:solidFill>
                   <a:srgbClr val="2E7D4F"/>
                 </a:solidFill>
@@ -5219,35 +5255,13 @@
               <a:t>0 % folded</a:t>
             </a:r>
             <a:r>
-              <a:rPr sz="900" b="0" i="0">
+              <a:rPr sz="825" b="0" i="0">
                 <a:solidFill>
                   <a:srgbClr val="595959"/>
                 </a:solidFill>
                 <a:latin typeface="Consolas"/>
               </a:rPr>
-              <a:t> · max 5.0 mm</a:t>
-            </a:r>
-          </a:p>
-          <a:p>
-            <a:pPr algn="l">
-              <a:lnSpc>
-                <a:spcPct val="100000"/>
-              </a:lnSpc>
-              <a:spcBef>
-                <a:spcPts val="0"/>
-              </a:spcBef>
-              <a:spcAft>
-                <a:spcPts val="0"/>
-              </a:spcAft>
-            </a:pPr>
-            <a:r>
-              <a:rPr sz="787" b="0" i="0">
-                <a:solidFill>
-                  <a:srgbClr val="595959"/>
-                </a:solidFill>
-                <a:latin typeface="Poppins"/>
-              </a:rPr>
-              <a:t>subject_m: 0.57 / 0.40 mm · 0 % · max 3.8 mm</a:t>
+              <a:t> · max 5.0 / 3.8 mm</a:t>
             </a:r>
           </a:p>
         </p:txBody>
@@ -5261,7 +5275,7 @@
         <p:spPr>
           <a:xfrm>
             <a:off x="5897879" y="1152144"/>
-            <a:ext cx="0" cy="836676"/>
+            <a:ext cx="0" cy="562356"/>
           </a:xfrm>
           <a:prstGeom prst="line">
             <a:avLst/>
@@ -5295,8 +5309,8 @@
         </p:nvSpPr>
         <p:spPr>
           <a:xfrm>
-            <a:off x="5897879" y="2105406"/>
-            <a:ext cx="2811779" cy="946403"/>
+            <a:off x="5897879" y="1824228"/>
+            <a:ext cx="2811779" cy="672084"/>
           </a:xfrm>
           <a:prstGeom prst="roundRect">
             <a:avLst>
@@ -5328,7 +5342,7 @@
           </a:fontRef>
         </p:style>
         <p:txBody>
-          <a:bodyPr rtlCol="0" anchor="t" wrap="square" lIns="89154" rIns="89154" tIns="89154" bIns="89154">
+          <a:bodyPr rtlCol="0" anchor="t" wrap="square" lIns="68580" rIns="68580" tIns="68580" bIns="68580">
             <a:noAutofit/>
           </a:bodyPr>
           <a:lstStyle/>
@@ -5345,13 +5359,13 @@
               </a:spcAft>
             </a:pPr>
             <a:r>
-              <a:rPr sz="1200" b="1" i="0">
+              <a:rPr sz="900" b="1" i="0">
                 <a:solidFill>
                   <a:srgbClr val="212121"/>
                 </a:solidFill>
                 <a:latin typeface="Poppins"/>
               </a:rPr>
-              <a:t>FireANTs SyN CC</a:t>
+              <a:t>FireANTs · SyN, CC</a:t>
             </a:r>
           </a:p>
           <a:p>
@@ -5363,17 +5377,53 @@
                 <a:spcPts val="0"/>
               </a:spcBef>
               <a:spcAft>
-                <a:spcPts val="0"/>
-              </a:spcAft>
-            </a:pPr>
-            <a:r>
-              <a:rPr sz="1650" b="1" i="0">
+                <a:spcPts val="75"/>
+              </a:spcAft>
+            </a:pPr>
+            <a:r>
+              <a:rPr sz="750" b="0" i="0">
+                <a:solidFill>
+                  <a:srgbClr val="595959"/>
+                </a:solidFill>
+                <a:latin typeface="Consolas"/>
+              </a:rPr>
+              <a:t>v </a:t>
+            </a:r>
+            <a:r>
+              <a:rPr sz="1050" b="1" i="0">
                 <a:solidFill>
                   <a:srgbClr val="212121"/>
                 </a:solidFill>
                 <a:latin typeface="Consolas"/>
               </a:rPr>
-              <a:t>0.40 / 0.40 mm</a:t>
+              <a:t>0.40 / 0.40</a:t>
+            </a:r>
+            <a:r>
+              <a:rPr sz="750" b="0" i="0">
+                <a:solidFill>
+                  <a:srgbClr val="595959"/>
+                </a:solidFill>
+                <a:latin typeface="Consolas"/>
+              </a:rPr>
+              <a:t>   m </a:t>
+            </a:r>
+            <a:r>
+              <a:rPr sz="1050" b="1" i="0">
+                <a:solidFill>
+                  <a:srgbClr val="212121"/>
+                </a:solidFill>
+                <a:latin typeface="Consolas"/>
+              </a:rPr>
+              <a:t>0.40 / 0.40</a:t>
+            </a:r>
+            <a:r>
+              <a:rPr sz="750" b="0" i="0">
+                <a:solidFill>
+                  <a:srgbClr val="595959"/>
+                </a:solidFill>
+                <a:latin typeface="Consolas"/>
+              </a:rPr>
+              <a:t> mm</a:t>
             </a:r>
           </a:p>
           <a:p>
@@ -5385,11 +5435,11 @@
                 <a:spcPts val="0"/>
               </a:spcBef>
               <a:spcAft>
-                <a:spcPts val="75"/>
-              </a:spcAft>
-            </a:pPr>
-            <a:r>
-              <a:rPr sz="900" b="1" i="0">
+                <a:spcPts val="0"/>
+              </a:spcAft>
+            </a:pPr>
+            <a:r>
+              <a:rPr sz="825" b="1" i="0">
                 <a:solidFill>
                   <a:srgbClr val="2E7D4F"/>
                 </a:solidFill>
@@ -5398,35 +5448,13 @@
               <a:t>0 % folded</a:t>
             </a:r>
             <a:r>
-              <a:rPr sz="900" b="0" i="0">
+              <a:rPr sz="825" b="0" i="0">
                 <a:solidFill>
                   <a:srgbClr val="595959"/>
                 </a:solidFill>
                 <a:latin typeface="Consolas"/>
               </a:rPr>
-              <a:t> · max 2.7 mm</a:t>
-            </a:r>
-          </a:p>
-          <a:p>
-            <a:pPr algn="l">
-              <a:lnSpc>
-                <a:spcPct val="100000"/>
-              </a:lnSpc>
-              <a:spcBef>
-                <a:spcPts val="0"/>
-              </a:spcBef>
-              <a:spcAft>
-                <a:spcPts val="0"/>
-              </a:spcAft>
-            </a:pPr>
-            <a:r>
-              <a:rPr sz="787" b="0" i="0">
-                <a:solidFill>
-                  <a:srgbClr val="595959"/>
-                </a:solidFill>
-                <a:latin typeface="Poppins"/>
-              </a:rPr>
-              <a:t>subject_m: 0.40 / 0.40 mm · 0 % · max 2.1 mm</a:t>
+              <a:t> · max 2.7 / 2.1 mm</a:t>
             </a:r>
           </a:p>
         </p:txBody>
@@ -5439,8 +5467,8 @@
         </p:nvCxnSpPr>
         <p:spPr>
           <a:xfrm>
-            <a:off x="5897879" y="2160270"/>
-            <a:ext cx="0" cy="836676"/>
+            <a:off x="5897879" y="1879092"/>
+            <a:ext cx="0" cy="562356"/>
           </a:xfrm>
           <a:prstGeom prst="line">
             <a:avLst/>
@@ -5474,8 +5502,8 @@
         </p:nvSpPr>
         <p:spPr>
           <a:xfrm>
-            <a:off x="5897879" y="3113532"/>
-            <a:ext cx="2811779" cy="946403"/>
+            <a:off x="5897879" y="2551176"/>
+            <a:ext cx="2811779" cy="672084"/>
           </a:xfrm>
           <a:prstGeom prst="roundRect">
             <a:avLst>
@@ -5507,7 +5535,7 @@
           </a:fontRef>
         </p:style>
         <p:txBody>
-          <a:bodyPr rtlCol="0" anchor="t" wrap="square" lIns="89154" rIns="89154" tIns="89154" bIns="89154">
+          <a:bodyPr rtlCol="0" anchor="t" wrap="square" lIns="68580" rIns="68580" tIns="68580" bIns="68580">
             <a:noAutofit/>
           </a:bodyPr>
           <a:lstStyle/>
@@ -5524,13 +5552,13 @@
               </a:spcAft>
             </a:pPr>
             <a:r>
-              <a:rPr sz="1200" b="1" i="0">
+              <a:rPr sz="900" b="1" i="0">
                 <a:solidFill>
                   <a:srgbClr val="212121"/>
                 </a:solidFill>
                 <a:latin typeface="Poppins"/>
               </a:rPr>
-              <a:t>ConvexAdam MIND</a:t>
+              <a:t>FireANTs · IMPACT (TotalSegmentator)</a:t>
             </a:r>
           </a:p>
           <a:p>
@@ -5542,17 +5570,53 @@
                 <a:spcPts val="0"/>
               </a:spcBef>
               <a:spcAft>
-                <a:spcPts val="0"/>
-              </a:spcAft>
-            </a:pPr>
-            <a:r>
-              <a:rPr sz="1650" b="1" i="0">
+                <a:spcPts val="75"/>
+              </a:spcAft>
+            </a:pPr>
+            <a:r>
+              <a:rPr sz="750" b="0" i="0">
+                <a:solidFill>
+                  <a:srgbClr val="595959"/>
+                </a:solidFill>
+                <a:latin typeface="Consolas"/>
+              </a:rPr>
+              <a:t>v </a:t>
+            </a:r>
+            <a:r>
+              <a:rPr sz="1050" b="1" i="0">
                 <a:solidFill>
                   <a:srgbClr val="212121"/>
                 </a:solidFill>
                 <a:latin typeface="Consolas"/>
               </a:rPr>
-              <a:t>0.57 / 0.40 mm</a:t>
+              <a:t>0.40 / 0.40</a:t>
+            </a:r>
+            <a:r>
+              <a:rPr sz="750" b="0" i="0">
+                <a:solidFill>
+                  <a:srgbClr val="595959"/>
+                </a:solidFill>
+                <a:latin typeface="Consolas"/>
+              </a:rPr>
+              <a:t>   m </a:t>
+            </a:r>
+            <a:r>
+              <a:rPr sz="1050" b="1" i="0">
+                <a:solidFill>
+                  <a:srgbClr val="212121"/>
+                </a:solidFill>
+                <a:latin typeface="Consolas"/>
+              </a:rPr>
+              <a:t>0.57 / 0.57</a:t>
+            </a:r>
+            <a:r>
+              <a:rPr sz="750" b="0" i="0">
+                <a:solidFill>
+                  <a:srgbClr val="595959"/>
+                </a:solidFill>
+                <a:latin typeface="Consolas"/>
+              </a:rPr>
+              <a:t> mm</a:t>
             </a:r>
           </a:p>
           <a:p>
@@ -5564,48 +5628,26 @@
                 <a:spcPts val="0"/>
               </a:spcBef>
               <a:spcAft>
-                <a:spcPts val="75"/>
-              </a:spcAft>
-            </a:pPr>
-            <a:r>
-              <a:rPr sz="900" b="1" i="0">
-                <a:solidFill>
-                  <a:srgbClr val="B03A2E"/>
+                <a:spcPts val="0"/>
+              </a:spcAft>
+            </a:pPr>
+            <a:r>
+              <a:rPr sz="825" b="1" i="0">
+                <a:solidFill>
+                  <a:srgbClr val="2E7D4F"/>
                 </a:solidFill>
                 <a:latin typeface="Consolas"/>
               </a:rPr>
-              <a:t>1.6 % folded</a:t>
-            </a:r>
-            <a:r>
-              <a:rPr sz="900" b="0" i="0">
+              <a:t>0 % folded</a:t>
+            </a:r>
+            <a:r>
+              <a:rPr sz="825" b="0" i="0">
                 <a:solidFill>
                   <a:srgbClr val="595959"/>
                 </a:solidFill>
                 <a:latin typeface="Consolas"/>
               </a:rPr>
-              <a:t> · max 13.5 mm</a:t>
-            </a:r>
-          </a:p>
-          <a:p>
-            <a:pPr algn="l">
-              <a:lnSpc>
-                <a:spcPct val="100000"/>
-              </a:lnSpc>
-              <a:spcBef>
-                <a:spcPts val="0"/>
-              </a:spcBef>
-              <a:spcAft>
-                <a:spcPts val="0"/>
-              </a:spcAft>
-            </a:pPr>
-            <a:r>
-              <a:rPr sz="787" b="0" i="0">
-                <a:solidFill>
-                  <a:srgbClr val="595959"/>
-                </a:solidFill>
-                <a:latin typeface="Poppins"/>
-              </a:rPr>
-              <a:t>subject_m: 0.57 / 0.40 mm · 1.6 % · max 14.5 mm</a:t>
+              <a:t> · max 2.6 / 2.5 mm</a:t>
             </a:r>
           </a:p>
         </p:txBody>
@@ -5618,15 +5660,15 @@
         </p:nvCxnSpPr>
         <p:spPr>
           <a:xfrm>
-            <a:off x="5897879" y="3168396"/>
-            <a:ext cx="0" cy="836676"/>
+            <a:off x="5897879" y="2606040"/>
+            <a:ext cx="0" cy="562356"/>
           </a:xfrm>
           <a:prstGeom prst="line">
             <a:avLst/>
           </a:prstGeom>
           <a:ln w="38100">
             <a:solidFill>
-              <a:srgbClr val="B03A2E"/>
+              <a:srgbClr val="2E7D4F"/>
             </a:solidFill>
           </a:ln>
         </p:spPr>
@@ -5647,14 +5689,207 @@
       </p:cxnSp>
       <p:sp>
         <p:nvSpPr>
-          <p:cNvPr id="19" name="TextBox 18"/>
+          <p:cNvPr id="19" name="Rounded Rectangle 18"/>
+          <p:cNvSpPr/>
+          <p:nvPr/>
+        </p:nvSpPr>
+        <p:spPr>
+          <a:xfrm>
+            <a:off x="5897879" y="3278124"/>
+            <a:ext cx="2811779" cy="672084"/>
+          </a:xfrm>
+          <a:prstGeom prst="roundRect">
+            <a:avLst>
+              <a:gd name="adj" fmla="val 6000"/>
+            </a:avLst>
+          </a:prstGeom>
+          <a:solidFill>
+            <a:srgbClr val="F4F5F7"/>
+          </a:solidFill>
+          <a:ln w="7143">
+            <a:solidFill>
+              <a:srgbClr val="D9D9D9"/>
+            </a:solidFill>
+          </a:ln>
+          <a:effectLst/>
+        </p:spPr>
+        <p:style>
+          <a:lnRef idx="1">
+            <a:schemeClr val="accent1"/>
+          </a:lnRef>
+          <a:fillRef idx="3">
+            <a:schemeClr val="accent1"/>
+          </a:fillRef>
+          <a:effectRef idx="2">
+            <a:schemeClr val="accent1"/>
+          </a:effectRef>
+          <a:fontRef idx="minor">
+            <a:schemeClr val="lt1"/>
+          </a:fontRef>
+        </p:style>
+        <p:txBody>
+          <a:bodyPr rtlCol="0" anchor="t" wrap="square" lIns="68580" rIns="68580" tIns="68580" bIns="68580">
+            <a:noAutofit/>
+          </a:bodyPr>
+          <a:lstStyle/>
+          <a:p>
+            <a:pPr algn="l">
+              <a:lnSpc>
+                <a:spcPct val="100000"/>
+              </a:lnSpc>
+              <a:spcBef>
+                <a:spcPts val="0"/>
+              </a:spcBef>
+              <a:spcAft>
+                <a:spcPts val="75"/>
+              </a:spcAft>
+            </a:pPr>
+            <a:r>
+              <a:rPr sz="900" b="1" i="0">
+                <a:solidFill>
+                  <a:srgbClr val="212121"/>
+                </a:solidFill>
+                <a:latin typeface="Poppins"/>
+              </a:rPr>
+              <a:t>ConvexAdam · MIND</a:t>
+            </a:r>
+          </a:p>
+          <a:p>
+            <a:pPr algn="l">
+              <a:lnSpc>
+                <a:spcPct val="100000"/>
+              </a:lnSpc>
+              <a:spcBef>
+                <a:spcPts val="0"/>
+              </a:spcBef>
+              <a:spcAft>
+                <a:spcPts val="75"/>
+              </a:spcAft>
+            </a:pPr>
+            <a:r>
+              <a:rPr sz="750" b="0" i="0">
+                <a:solidFill>
+                  <a:srgbClr val="595959"/>
+                </a:solidFill>
+                <a:latin typeface="Consolas"/>
+              </a:rPr>
+              <a:t>v </a:t>
+            </a:r>
+            <a:r>
+              <a:rPr sz="1050" b="1" i="0">
+                <a:solidFill>
+                  <a:srgbClr val="212121"/>
+                </a:solidFill>
+                <a:latin typeface="Consolas"/>
+              </a:rPr>
+              <a:t>0.57 / 0.40</a:t>
+            </a:r>
+            <a:r>
+              <a:rPr sz="750" b="0" i="0">
+                <a:solidFill>
+                  <a:srgbClr val="595959"/>
+                </a:solidFill>
+                <a:latin typeface="Consolas"/>
+              </a:rPr>
+              <a:t>   m </a:t>
+            </a:r>
+            <a:r>
+              <a:rPr sz="1050" b="1" i="0">
+                <a:solidFill>
+                  <a:srgbClr val="212121"/>
+                </a:solidFill>
+                <a:latin typeface="Consolas"/>
+              </a:rPr>
+              <a:t>0.57 / 0.40</a:t>
+            </a:r>
+            <a:r>
+              <a:rPr sz="750" b="0" i="0">
+                <a:solidFill>
+                  <a:srgbClr val="595959"/>
+                </a:solidFill>
+                <a:latin typeface="Consolas"/>
+              </a:rPr>
+              <a:t> mm</a:t>
+            </a:r>
+          </a:p>
+          <a:p>
+            <a:pPr algn="l">
+              <a:lnSpc>
+                <a:spcPct val="100000"/>
+              </a:lnSpc>
+              <a:spcBef>
+                <a:spcPts val="0"/>
+              </a:spcBef>
+              <a:spcAft>
+                <a:spcPts val="0"/>
+              </a:spcAft>
+            </a:pPr>
+            <a:r>
+              <a:rPr sz="825" b="1" i="0">
+                <a:solidFill>
+                  <a:srgbClr val="B03A2E"/>
+                </a:solidFill>
+                <a:latin typeface="Consolas"/>
+              </a:rPr>
+              <a:t>1.6 % folded</a:t>
+            </a:r>
+            <a:r>
+              <a:rPr sz="825" b="0" i="0">
+                <a:solidFill>
+                  <a:srgbClr val="595959"/>
+                </a:solidFill>
+                <a:latin typeface="Consolas"/>
+              </a:rPr>
+              <a:t> · max 13.5 / 14.5 mm</a:t>
+            </a:r>
+          </a:p>
+        </p:txBody>
+      </p:sp>
+      <p:cxnSp>
+        <p:nvCxnSpPr>
+          <p:cNvPr id="20" name="Connector 19"/>
+          <p:cNvCxnSpPr/>
+          <p:nvPr/>
+        </p:nvCxnSpPr>
+        <p:spPr>
+          <a:xfrm>
+            <a:off x="5897879" y="3332988"/>
+            <a:ext cx="0" cy="562356"/>
+          </a:xfrm>
+          <a:prstGeom prst="line">
+            <a:avLst/>
+          </a:prstGeom>
+          <a:ln w="38100">
+            <a:solidFill>
+              <a:srgbClr val="B03A2E"/>
+            </a:solidFill>
+          </a:ln>
+        </p:spPr>
+        <p:style>
+          <a:lnRef idx="2">
+            <a:schemeClr val="accent1"/>
+          </a:lnRef>
+          <a:fillRef idx="0">
+            <a:schemeClr val="accent1"/>
+          </a:fillRef>
+          <a:effectRef idx="1">
+            <a:schemeClr val="accent1"/>
+          </a:effectRef>
+          <a:fontRef idx="minor">
+            <a:schemeClr val="tx1"/>
+          </a:fontRef>
+        </p:style>
+      </p:cxnSp>
+      <p:sp>
+        <p:nvSpPr>
+          <p:cNvPr id="21" name="TextBox 20"/>
           <p:cNvSpPr txBox="1"/>
           <p:nvPr/>
         </p:nvSpPr>
         <p:spPr>
           <a:xfrm>
-            <a:off x="5897879" y="4128515"/>
-            <a:ext cx="2811779" cy="630936"/>
+            <a:off x="5897879" y="4032504"/>
+            <a:ext cx="2811779" cy="720090"/>
           </a:xfrm>
           <a:prstGeom prst="rect">
             <a:avLst/>
@@ -5679,20 +5914,20 @@
               </a:spcAft>
             </a:pPr>
             <a:r>
-              <a:rPr sz="787" b="0" i="0">
+              <a:rPr sz="750" b="0" i="0">
                 <a:solidFill>
                   <a:srgbClr val="595959"/>
                 </a:solidFill>
                 <a:latin typeface="Poppins"/>
               </a:rPr>
-              <a:t>subject_v shown; residual = median best shift in 12 mm windows (MI / gradients). Affine alone: 1.26 mm (v), 1.13 mm (m). Our measures, no official criterion.</a:t>
+              <a:t>residual: the median best shift in 12 mm windows (by MI / by gradients) for subject_v and subject_m; after the affine alone 1.26 and 1.13 mm. Our measures, no official criterion.</a:t>
             </a:r>
           </a:p>
         </p:txBody>
       </p:sp>
       <p:pic>
         <p:nvPicPr>
-          <p:cNvPr id="20" name="Picture 19" descr="image4.png"/>
+          <p:cNvPr id="22" name="Picture 21" descr="image4.png"/>
           <p:cNvPicPr>
             <a:picLocks noChangeAspect="1"/>
           </p:cNvPicPr>
@@ -5716,7 +5951,7 @@
       </p:pic>
       <p:sp>
         <p:nvSpPr>
-          <p:cNvPr id="21" name="TextBox 20"/>
+          <p:cNvPr id="23" name="TextBox 22"/>
           <p:cNvSpPr txBox="1"/>
           <p:nvPr/>
         </p:nvSpPr>
@@ -5761,7 +5996,7 @@
       </p:sp>
       <p:sp>
         <p:nvSpPr>
-          <p:cNvPr id="22" name="TextBox 21"/>
+          <p:cNvPr id="24" name="TextBox 23"/>
           <p:cNvSpPr txBox="1"/>
           <p:nvPr/>
         </p:nvSpPr>

</xml_diff>